<commit_message>
rename: Store Leaderboard -> Team Scorecard in deck
</commit_message>
<xml_diff>
--- a/public/lab/lp-dashboard/LP_Dashboard_Design_Concepts.pptx
+++ b/public/lab/lp-dashboard/LP_Dashboard_Design_Concepts.pptx
@@ -6299,7 +6299,7 @@
                 </a:solidFill>
                 <a:latin typeface="Trebuchet MS"/>
               </a:rPr>
-              <a:t>Company View: Store Leaderboard</a:t>
+              <a:t>Company View: Team Scorecard</a:t>
             </a:r>
           </a:p>
         </p:txBody>
@@ -18315,7 +18315,7 @@
                 </a:solidFill>
                 <a:latin typeface="Trebuchet MS"/>
               </a:rPr>
-              <a:t>Store Leaderboard</a:t>
+              <a:t>Team Scorecard</a:t>
             </a:r>
           </a:p>
         </p:txBody>
@@ -19581,7 +19581,7 @@
                 </a:solidFill>
                 <a:latin typeface="Calibri"/>
               </a:rPr>
-              <a:t>Recommendation: build both. They're two facets of the same data - a company tab (Leaderboard) and a per-store tab (Manager View). One build, two pages.</a:t>
+              <a:t>Recommendation: build both. They're two facets of the same data - a company tab (Team Scorecard) and a per-store tab (Manager View). One build, two pages.</a:t>
             </a:r>
           </a:p>
         </p:txBody>
@@ -21601,7 +21601,7 @@
                 </a:solidFill>
                 <a:latin typeface="Calibri"/>
               </a:rPr>
-              <a:t>Add 'Loss Prevention' section with a Leaderboard tab and a Manager View tab.</a:t>
+              <a:t>Add 'Loss Prevention' section with a Team Scorecard tab and a Manager View tab.</a:t>
             </a:r>
           </a:p>
         </p:txBody>

</xml_diff>